<commit_message>
Carry the Google Slides edits into the builder, web decks and PowerPoint files
- All decks: closing "Thank You !" slide
- L1: course objective + references slide, vector databases slide,
  five-days course table, wording edits from the Google Slides version
- L2: objectives, weak entity, composite attribute and SSN key wording
- L4: four categories, 7-step execution order with aggregates, subquery
  bullets, types of indexes slide (clustered / non-clustered / unique),
  index rules without the 2-4% rows, CTE/view/EXCEPT titles
- L5: plain-language definition with two design cases, anomaly wording,
  school example explanations, ITI / school / suppliers examples split
  into 1NF, 2NF and 3NF slides, lecturer email for Lesson 5

Co-Authored-By: Claude Opus 5.5 <noreply@anthropic.com>
Claude-Session: https://claude.ai/code/session_01R46jZmLWPYVdN2LncsYeT8
</commit_message>
<xml_diff>
--- a/pptx/ITI_Database_Course_Lesson_2_ERD.pptx
+++ b/pptx/ITI_Database_Course_Lesson_2_ERD.pptx
@@ -48,6 +48,7 @@
     <p:sldId id="293" r:id="rId42"/>
     <p:sldId id="294" r:id="rId43"/>
     <p:sldId id="295" r:id="rId44"/>
+    <p:sldId id="296" r:id="rId45"/>
   </p:sldIdLst>
   <p:sldSz cy="10287000" cx="18288000"/>
   <p:notesSz cx="10287000" cy="18288000"/>
@@ -4154,7 +4155,7 @@
                 </a:solidFill>
                 <a:latin typeface="Courier New"/>
               </a:rPr>
-              <a:t>10/40</a:t>
+              <a:t>10/41</a:t>
             </a:r>
           </a:p>
         </p:txBody>
@@ -5027,7 +5028,7 @@
                 </a:solidFill>
                 <a:latin typeface="Courier New"/>
               </a:rPr>
-              <a:t>11/40</a:t>
+              <a:t>11/41</a:t>
             </a:r>
           </a:p>
         </p:txBody>
@@ -5488,7 +5489,7 @@
                           </a:solidFill>
                           <a:latin typeface="Calibri"/>
                         </a:rPr>
-                        <a:t>Made of smaller parts</a:t>
+                        <a:t>Made of parts</a:t>
                       </a:r>
                     </a:p>
                   </a:txBody>
@@ -6347,7 +6348,7 @@
                 </a:solidFill>
                 <a:latin typeface="Courier New"/>
               </a:rPr>
-              <a:t>12/40</a:t>
+              <a:t>12/41</a:t>
             </a:r>
           </a:p>
         </p:txBody>
@@ -7363,7 +7364,7 @@
                 </a:solidFill>
                 <a:latin typeface="Courier New"/>
               </a:rPr>
-              <a:t>13/40</a:t>
+              <a:t>13/41</a:t>
             </a:r>
           </a:p>
         </p:txBody>
@@ -7587,7 +7588,7 @@
                 </a:solidFill>
                 <a:latin typeface="Courier New"/>
               </a:rPr>
-              <a:t>14/40</a:t>
+              <a:t>14/41</a:t>
             </a:r>
           </a:p>
         </p:txBody>
@@ -8308,7 +8309,7 @@
                 </a:solidFill>
                 <a:latin typeface="Courier New"/>
               </a:rPr>
-              <a:t>15/40</a:t>
+              <a:t>15/41</a:t>
             </a:r>
           </a:p>
         </p:txBody>
@@ -9150,7 +9151,7 @@
                 </a:solidFill>
                 <a:latin typeface="Courier New"/>
               </a:rPr>
-              <a:t>16/40</a:t>
+              <a:t>16/41</a:t>
             </a:r>
           </a:p>
         </p:txBody>
@@ -10119,7 +10120,7 @@
                 </a:solidFill>
                 <a:latin typeface="Courier New"/>
               </a:rPr>
-              <a:t>17/40</a:t>
+              <a:t>17/41</a:t>
             </a:r>
           </a:p>
         </p:txBody>
@@ -10965,7 +10966,7 @@
                 </a:solidFill>
                 <a:latin typeface="Courier New"/>
               </a:rPr>
-              <a:t>18/40</a:t>
+              <a:t>18/41</a:t>
             </a:r>
           </a:p>
         </p:txBody>
@@ -11819,7 +11820,7 @@
                 </a:solidFill>
                 <a:latin typeface="Courier New"/>
               </a:rPr>
-              <a:t>19/40</a:t>
+              <a:t>19/41</a:t>
             </a:r>
           </a:p>
         </p:txBody>
@@ -12390,7 +12391,7 @@
                 </a:solidFill>
                 <a:latin typeface="Courier New"/>
               </a:rPr>
-              <a:t>02/40</a:t>
+              <a:t>02/41</a:t>
             </a:r>
           </a:p>
         </p:txBody>
@@ -13200,7 +13201,7 @@
                 </a:solidFill>
                 <a:latin typeface="Courier New"/>
               </a:rPr>
-              <a:t>20/40</a:t>
+              <a:t>20/41</a:t>
             </a:r>
           </a:p>
         </p:txBody>
@@ -14773,7 +14774,7 @@
                 </a:solidFill>
                 <a:latin typeface="Courier New"/>
               </a:rPr>
-              <a:t>21/40</a:t>
+              <a:t>21/41</a:t>
             </a:r>
           </a:p>
         </p:txBody>
@@ -15740,7 +15741,7 @@
                 </a:solidFill>
                 <a:latin typeface="Courier New"/>
               </a:rPr>
-              <a:t>22/40</a:t>
+              <a:t>22/41</a:t>
             </a:r>
           </a:p>
         </p:txBody>
@@ -17058,7 +17059,7 @@
                 </a:solidFill>
                 <a:latin typeface="Courier New"/>
               </a:rPr>
-              <a:t>23/40</a:t>
+              <a:t>23/41</a:t>
             </a:r>
           </a:p>
         </p:txBody>
@@ -17282,7 +17283,7 @@
                 </a:solidFill>
                 <a:latin typeface="Courier New"/>
               </a:rPr>
-              <a:t>24/40</a:t>
+              <a:t>24/41</a:t>
             </a:r>
           </a:p>
         </p:txBody>
@@ -18721,7 +18722,7 @@
                 </a:solidFill>
                 <a:latin typeface="Courier New"/>
               </a:rPr>
-              <a:t>25/40</a:t>
+              <a:t>25/41</a:t>
             </a:r>
           </a:p>
         </p:txBody>
@@ -19205,7 +19206,7 @@
                 </a:solidFill>
                 <a:latin typeface="Courier New"/>
               </a:rPr>
-              <a:t>26/40</a:t>
+              <a:t>26/41</a:t>
             </a:r>
           </a:p>
         </p:txBody>
@@ -19337,7 +19338,7 @@
                 </a:solidFill>
                 <a:latin typeface="Calibri"/>
               </a:rPr>
-              <a:t>name, social security number, address, salary, gender and birth date</a:t>
+              <a:t>name, social security number (key), address, salary, gender and birth date</a:t>
             </a:r>
             <a:r>
               <a:rPr sz="2898" b="0" i="0" u="none">
@@ -19653,7 +19654,7 @@
                 </a:solidFill>
                 <a:latin typeface="Courier New"/>
               </a:rPr>
-              <a:t>27/40</a:t>
+              <a:t>27/41</a:t>
             </a:r>
           </a:p>
         </p:txBody>
@@ -21791,7 +21792,7 @@
                 </a:solidFill>
                 <a:latin typeface="Courier New"/>
               </a:rPr>
-              <a:t>28/40</a:t>
+              <a:t>28/41</a:t>
             </a:r>
           </a:p>
         </p:txBody>
@@ -22655,7 +22656,7 @@
                 </a:solidFill>
                 <a:latin typeface="Courier New"/>
               </a:rPr>
-              <a:t>29/40</a:t>
+              <a:t>29/41</a:t>
             </a:r>
           </a:p>
         </p:txBody>
@@ -23507,7 +23508,7 @@
                 </a:solidFill>
                 <a:latin typeface="Courier New"/>
               </a:rPr>
-              <a:t>03/40</a:t>
+              <a:t>03/41</a:t>
             </a:r>
           </a:p>
         </p:txBody>
@@ -23904,7 +23905,7 @@
                 </a:solidFill>
                 <a:latin typeface="Calibri"/>
               </a:rPr>
-              <a:t> and choose </a:t>
+              <a:t> and </a:t>
             </a:r>
             <a:r>
               <a:rPr sz="2898" b="1" i="0" u="none">
@@ -23913,7 +23914,7 @@
                 </a:solidFill>
                 <a:latin typeface="Calibri"/>
               </a:rPr>
-              <a:t>keys</a:t>
+              <a:t>key attributes</a:t>
             </a:r>
           </a:p>
         </p:txBody>
@@ -24395,7 +24396,7 @@
                 </a:solidFill>
                 <a:latin typeface="Courier New"/>
               </a:rPr>
-              <a:t>30/40</a:t>
+              <a:t>30/41</a:t>
             </a:r>
           </a:p>
         </p:txBody>
@@ -24619,7 +24620,7 @@
                 </a:solidFill>
                 <a:latin typeface="Courier New"/>
               </a:rPr>
-              <a:t>31/40</a:t>
+              <a:t>31/41</a:t>
             </a:r>
           </a:p>
         </p:txBody>
@@ -25067,7 +25068,7 @@
                 </a:solidFill>
                 <a:latin typeface="Courier New"/>
               </a:rPr>
-              <a:t>32/40</a:t>
+              <a:t>32/41</a:t>
             </a:r>
           </a:p>
         </p:txBody>
@@ -25565,7 +25566,7 @@
                 </a:solidFill>
                 <a:latin typeface="Courier New"/>
               </a:rPr>
-              <a:t>33/40</a:t>
+              <a:t>33/41</a:t>
             </a:r>
           </a:p>
         </p:txBody>
@@ -26031,7 +26032,7 @@
                 </a:solidFill>
                 <a:latin typeface="Courier New"/>
               </a:rPr>
-              <a:t>34/40</a:t>
+              <a:t>34/41</a:t>
             </a:r>
           </a:p>
         </p:txBody>
@@ -26565,7 +26566,7 @@
                 </a:solidFill>
                 <a:latin typeface="Courier New"/>
               </a:rPr>
-              <a:t>35/40</a:t>
+              <a:t>35/41</a:t>
             </a:r>
           </a:p>
         </p:txBody>
@@ -27099,7 +27100,7 @@
                 </a:solidFill>
                 <a:latin typeface="Courier New"/>
               </a:rPr>
-              <a:t>36/40</a:t>
+              <a:t>36/41</a:t>
             </a:r>
           </a:p>
         </p:txBody>
@@ -27633,7 +27634,7 @@
                 </a:solidFill>
                 <a:latin typeface="Courier New"/>
               </a:rPr>
-              <a:t>37/40</a:t>
+              <a:t>37/41</a:t>
             </a:r>
           </a:p>
         </p:txBody>
@@ -28479,7 +28480,7 @@
                 </a:solidFill>
                 <a:latin typeface="Courier New"/>
               </a:rPr>
-              <a:t>38/40</a:t>
+              <a:t>38/41</a:t>
             </a:r>
           </a:p>
         </p:txBody>
@@ -29331,7 +29332,7 @@
                 </a:solidFill>
                 <a:latin typeface="Courier New"/>
               </a:rPr>
-              <a:t>39/40</a:t>
+              <a:t>39/41</a:t>
             </a:r>
           </a:p>
         </p:txBody>
@@ -30024,7 +30025,7 @@
                 </a:solidFill>
                 <a:latin typeface="Courier New"/>
               </a:rPr>
-              <a:t>04/40</a:t>
+              <a:t>04/41</a:t>
             </a:r>
           </a:p>
         </p:txBody>
@@ -30435,6 +30436,106 @@
 </p:sld>
 </file>
 
+<file path=ppt/slides/slide41.xml><?xml version="1.0" encoding="utf-8"?>
+<p:sld xmlns:a="http://schemas.openxmlformats.org/drawingml/2006/main" xmlns:p="http://schemas.openxmlformats.org/presentationml/2006/main" xmlns:r="http://schemas.openxmlformats.org/officeDocument/2006/relationships">
+  <p:cSld>
+    <p:bg>
+      <p:bgPr>
+        <a:solidFill>
+          <a:srgbClr val="0F172A"/>
+        </a:solidFill>
+        <a:effectLst/>
+      </p:bgPr>
+    </p:bg>
+    <p:spTree>
+      <p:nvGrpSpPr>
+        <p:cNvPr id="1" name=""/>
+        <p:cNvGrpSpPr/>
+        <p:nvPr/>
+      </p:nvGrpSpPr>
+      <p:grpSpPr/>
+      <p:sp>
+        <p:nvSpPr>
+          <p:cNvPr id="2" name="TextBox 1"/>
+          <p:cNvSpPr txBox="1"/>
+          <p:nvPr/>
+        </p:nvSpPr>
+        <p:spPr>
+          <a:xfrm>
+            <a:off x="914400" y="3810000"/>
+            <a:ext cx="16459200" cy="419100"/>
+          </a:xfrm>
+          <a:prstGeom prst="rect">
+            <a:avLst/>
+          </a:prstGeom>
+          <a:noFill/>
+        </p:spPr>
+        <p:txBody>
+          <a:bodyPr wrap="square" lIns="0" rIns="0" tIns="0" bIns="0" anchor="t"/>
+          <a:lstStyle/>
+          <a:p>
+            <a:pPr algn="ctr">
+              <a:lnSpc>
+                <a:spcPct val="111800"/>
+              </a:lnSpc>
+            </a:pPr>
+            <a:r>
+              <a:rPr sz="2250" b="1" i="0" u="none">
+                <a:solidFill>
+                  <a:srgbClr val="F87171"/>
+                </a:solidFill>
+                <a:latin typeface="Arial"/>
+              </a:rPr>
+              <a:t>ITI · DATABASE FUNDAMENTALS</a:t>
+            </a:r>
+          </a:p>
+        </p:txBody>
+      </p:sp>
+      <p:sp>
+        <p:nvSpPr>
+          <p:cNvPr id="3" name="TextBox 2"/>
+          <p:cNvSpPr txBox="1"/>
+          <p:nvPr/>
+        </p:nvSpPr>
+        <p:spPr>
+          <a:xfrm>
+            <a:off x="914400" y="4476750"/>
+            <a:ext cx="16459200" cy="1714500"/>
+          </a:xfrm>
+          <a:prstGeom prst="rect">
+            <a:avLst/>
+          </a:prstGeom>
+          <a:noFill/>
+        </p:spPr>
+        <p:txBody>
+          <a:bodyPr wrap="square" lIns="0" rIns="0" tIns="0" bIns="0" anchor="t"/>
+          <a:lstStyle/>
+          <a:p>
+            <a:pPr algn="ctr">
+              <a:lnSpc>
+                <a:spcPct val="86000"/>
+              </a:lnSpc>
+            </a:pPr>
+            <a:r>
+              <a:rPr sz="10500" b="1" i="0" u="none">
+                <a:solidFill>
+                  <a:srgbClr val="FFFFFF"/>
+                </a:solidFill>
+                <a:latin typeface="Arial"/>
+              </a:rPr>
+              <a:t>Thank You !</a:t>
+            </a:r>
+          </a:p>
+        </p:txBody>
+      </p:sp>
+    </p:spTree>
+  </p:cSld>
+  <p:clrMapOvr>
+    <a:masterClrMapping/>
+  </p:clrMapOvr>
+</p:sld>
+</file>
+
 <file path=ppt/slides/slide5.xml><?xml version="1.0" encoding="utf-8"?>
 <p:sld xmlns:a="http://schemas.openxmlformats.org/drawingml/2006/main" xmlns:p="http://schemas.openxmlformats.org/presentationml/2006/main" xmlns:r="http://schemas.openxmlformats.org/officeDocument/2006/relationships">
   <p:cSld>
@@ -30535,7 +30636,7 @@
                 </a:solidFill>
                 <a:latin typeface="Courier New"/>
               </a:rPr>
-              <a:t>05/40</a:t>
+              <a:t>05/41</a:t>
             </a:r>
           </a:p>
         </p:txBody>
@@ -31396,7 +31497,7 @@
                 </a:solidFill>
                 <a:latin typeface="Courier New"/>
               </a:rPr>
-              <a:t>06/40</a:t>
+              <a:t>06/41</a:t>
             </a:r>
           </a:p>
         </p:txBody>
@@ -32114,7 +32215,7 @@
                 </a:solidFill>
                 <a:latin typeface="Courier New"/>
               </a:rPr>
-              <a:t>07/40</a:t>
+              <a:t>07/41</a:t>
             </a:r>
           </a:p>
         </p:txBody>
@@ -33360,7 +33461,7 @@
                 </a:solidFill>
                 <a:latin typeface="Courier New"/>
               </a:rPr>
-              <a:t>08/40</a:t>
+              <a:t>08/41</a:t>
             </a:r>
           </a:p>
         </p:txBody>
@@ -33851,7 +33952,7 @@
         <p:spPr>
           <a:xfrm>
             <a:off x="1219200" y="6096000"/>
-            <a:ext cx="7810500" cy="922743"/>
+            <a:ext cx="7810500" cy="1218933"/>
           </a:xfrm>
           <a:prstGeom prst="rect">
             <a:avLst/>
@@ -33946,7 +34047,7 @@
                 </a:solidFill>
                 <a:latin typeface="Calibri"/>
               </a:rPr>
-              <a:t> (double diamond). Its participation is always </a:t>
+              <a:t> (double diamond). And its participation is always </a:t>
             </a:r>
             <a:r>
               <a:rPr sz="1794" b="1" i="0" u="none">
@@ -34077,7 +34178,7 @@
                 </a:solidFill>
                 <a:latin typeface="Courier New"/>
               </a:rPr>
-              <a:t>09/40</a:t>
+              <a:t>09/41</a:t>
             </a:r>
           </a:p>
         </p:txBody>

</xml_diff>